<commit_message>
fix figure paths and add librsvg2-bin for DOCX SVG rendering
- Fix image paths in manuscript.qmd to use ../ prefix so figures resolve
  correctly from the rendered output location (result/src/)
- Fix p_value → p_bonferroni column name in correlation table
- Add librsvg2-bin to Dockerfile for SVG-to-DOCX conversion
- Update flow diagram SVG and PPTX assets

Co-Authored-By: Claude Opus 4.6 <noreply@anthropic.com>
</commit_message>
<xml_diff>
--- a/src/assets/flow_of_feedback_and_evaluation/flow_of_feedback_and_evaluation.pptx
+++ b/src/assets/flow_of_feedback_and_evaluation/flow_of_feedback_and_evaluation.pptx
@@ -261,7 +261,7 @@
           <a:p>
             <a:fld id="{A4416203-5805-4EEC-B841-2D7EE4C2385A}" type="datetimeFigureOut">
               <a:rPr kumimoji="1" lang="ja-JP" altLang="en-US" smtClean="0"/>
-              <a:t>2025/11/25</a:t>
+              <a:t>2026/3/1</a:t>
             </a:fld>
             <a:endParaRPr kumimoji="1" lang="ja-JP" altLang="en-US"/>
           </a:p>
@@ -461,7 +461,7 @@
           <a:p>
             <a:fld id="{A4416203-5805-4EEC-B841-2D7EE4C2385A}" type="datetimeFigureOut">
               <a:rPr kumimoji="1" lang="ja-JP" altLang="en-US" smtClean="0"/>
-              <a:t>2025/11/25</a:t>
+              <a:t>2026/3/1</a:t>
             </a:fld>
             <a:endParaRPr kumimoji="1" lang="ja-JP" altLang="en-US"/>
           </a:p>
@@ -671,7 +671,7 @@
           <a:p>
             <a:fld id="{A4416203-5805-4EEC-B841-2D7EE4C2385A}" type="datetimeFigureOut">
               <a:rPr kumimoji="1" lang="ja-JP" altLang="en-US" smtClean="0"/>
-              <a:t>2025/11/25</a:t>
+              <a:t>2026/3/1</a:t>
             </a:fld>
             <a:endParaRPr kumimoji="1" lang="ja-JP" altLang="en-US"/>
           </a:p>
@@ -871,7 +871,7 @@
           <a:p>
             <a:fld id="{A4416203-5805-4EEC-B841-2D7EE4C2385A}" type="datetimeFigureOut">
               <a:rPr kumimoji="1" lang="ja-JP" altLang="en-US" smtClean="0"/>
-              <a:t>2025/11/25</a:t>
+              <a:t>2026/3/1</a:t>
             </a:fld>
             <a:endParaRPr kumimoji="1" lang="ja-JP" altLang="en-US"/>
           </a:p>
@@ -1147,7 +1147,7 @@
           <a:p>
             <a:fld id="{A4416203-5805-4EEC-B841-2D7EE4C2385A}" type="datetimeFigureOut">
               <a:rPr kumimoji="1" lang="ja-JP" altLang="en-US" smtClean="0"/>
-              <a:t>2025/11/25</a:t>
+              <a:t>2026/3/1</a:t>
             </a:fld>
             <a:endParaRPr kumimoji="1" lang="ja-JP" altLang="en-US"/>
           </a:p>
@@ -1415,7 +1415,7 @@
           <a:p>
             <a:fld id="{A4416203-5805-4EEC-B841-2D7EE4C2385A}" type="datetimeFigureOut">
               <a:rPr kumimoji="1" lang="ja-JP" altLang="en-US" smtClean="0"/>
-              <a:t>2025/11/25</a:t>
+              <a:t>2026/3/1</a:t>
             </a:fld>
             <a:endParaRPr kumimoji="1" lang="ja-JP" altLang="en-US"/>
           </a:p>
@@ -1830,7 +1830,7 @@
           <a:p>
             <a:fld id="{A4416203-5805-4EEC-B841-2D7EE4C2385A}" type="datetimeFigureOut">
               <a:rPr kumimoji="1" lang="ja-JP" altLang="en-US" smtClean="0"/>
-              <a:t>2025/11/25</a:t>
+              <a:t>2026/3/1</a:t>
             </a:fld>
             <a:endParaRPr kumimoji="1" lang="ja-JP" altLang="en-US"/>
           </a:p>
@@ -1972,7 +1972,7 @@
           <a:p>
             <a:fld id="{A4416203-5805-4EEC-B841-2D7EE4C2385A}" type="datetimeFigureOut">
               <a:rPr kumimoji="1" lang="ja-JP" altLang="en-US" smtClean="0"/>
-              <a:t>2025/11/25</a:t>
+              <a:t>2026/3/1</a:t>
             </a:fld>
             <a:endParaRPr kumimoji="1" lang="ja-JP" altLang="en-US"/>
           </a:p>
@@ -2085,7 +2085,7 @@
           <a:p>
             <a:fld id="{A4416203-5805-4EEC-B841-2D7EE4C2385A}" type="datetimeFigureOut">
               <a:rPr kumimoji="1" lang="ja-JP" altLang="en-US" smtClean="0"/>
-              <a:t>2025/11/25</a:t>
+              <a:t>2026/3/1</a:t>
             </a:fld>
             <a:endParaRPr kumimoji="1" lang="ja-JP" altLang="en-US"/>
           </a:p>
@@ -2398,7 +2398,7 @@
           <a:p>
             <a:fld id="{A4416203-5805-4EEC-B841-2D7EE4C2385A}" type="datetimeFigureOut">
               <a:rPr kumimoji="1" lang="ja-JP" altLang="en-US" smtClean="0"/>
-              <a:t>2025/11/25</a:t>
+              <a:t>2026/3/1</a:t>
             </a:fld>
             <a:endParaRPr kumimoji="1" lang="ja-JP" altLang="en-US"/>
           </a:p>
@@ -2687,7 +2687,7 @@
           <a:p>
             <a:fld id="{A4416203-5805-4EEC-B841-2D7EE4C2385A}" type="datetimeFigureOut">
               <a:rPr kumimoji="1" lang="ja-JP" altLang="en-US" smtClean="0"/>
-              <a:t>2025/11/25</a:t>
+              <a:t>2026/3/1</a:t>
             </a:fld>
             <a:endParaRPr kumimoji="1" lang="ja-JP" altLang="en-US"/>
           </a:p>
@@ -2930,7 +2930,7 @@
           <a:p>
             <a:fld id="{A4416203-5805-4EEC-B841-2D7EE4C2385A}" type="datetimeFigureOut">
               <a:rPr kumimoji="1" lang="ja-JP" altLang="en-US" smtClean="0"/>
-              <a:t>2025/11/25</a:t>
+              <a:t>2026/3/1</a:t>
             </a:fld>
             <a:endParaRPr kumimoji="1" lang="ja-JP" altLang="en-US"/>
           </a:p>
@@ -3401,7 +3401,7 @@
         <p:spPr>
           <a:xfrm>
             <a:off x="560618" y="2698031"/>
-            <a:ext cx="1752467" cy="600164"/>
+            <a:ext cx="1917346" cy="430887"/>
           </a:xfrm>
           <a:prstGeom prst="rect">
             <a:avLst/>
@@ -3420,7 +3420,7 @@
             </a:r>
             <a:r>
               <a:rPr lang="en-US" altLang="ja-JP" sz="1100" dirty="0"/>
-              <a:t>clerkship logs in electric-portfolio</a:t>
+              <a:t>clerkship logs in e-portfolio</a:t>
             </a:r>
             <a:endParaRPr kumimoji="1" lang="ja-JP" altLang="en-US" sz="1100" dirty="0"/>
           </a:p>

</xml_diff>